<commit_message>
Add new graphs and update report generation
</commit_message>
<xml_diff>
--- a/data/utility_reporting/reports/200281 Analysis January - June 2025.pptx
+++ b/data/utility_reporting/reports/200281 Analysis January - June 2025.pptx
@@ -155,7 +155,7 @@
       </p:grpSpPr>
       <p:sp>
         <p:nvSpPr>
-          <p:cNvPr id="61568798" name="Header Placeholder 1"/>
+          <p:cNvPr id="269212210" name="Header Placeholder 1"/>
           <p:cNvSpPr>
             <a:spLocks noGrp="1"/>
           </p:cNvSpPr>
@@ -189,7 +189,7 @@
       </p:sp>
       <p:sp>
         <p:nvSpPr>
-          <p:cNvPr id="75398653" name="Date Placeholder 2"/>
+          <p:cNvPr id="458298576" name="Date Placeholder 2"/>
           <p:cNvSpPr>
             <a:spLocks noGrp="1"/>
           </p:cNvSpPr>
@@ -227,7 +227,7 @@
       </p:sp>
       <p:sp>
         <p:nvSpPr>
-          <p:cNvPr id="27517480" name="Slide Image Placeholder 3"/>
+          <p:cNvPr id="840258345" name="Slide Image Placeholder 3"/>
           <p:cNvSpPr>
             <a:spLocks noChangeAspect="1" noGrp="1" noRot="1"/>
           </p:cNvSpPr>
@@ -263,7 +263,7 @@
       </p:sp>
       <p:sp>
         <p:nvSpPr>
-          <p:cNvPr id="1790485375" name="Notes Placeholder 4"/>
+          <p:cNvPr id="1806858748" name="Notes Placeholder 4"/>
           <p:cNvSpPr>
             <a:spLocks noGrp="1"/>
           </p:cNvSpPr>
@@ -337,7 +337,7 @@
       </p:sp>
       <p:sp>
         <p:nvSpPr>
-          <p:cNvPr id="1888205877" name="Footer Placeholder 5"/>
+          <p:cNvPr id="2023347253" name="Footer Placeholder 5"/>
           <p:cNvSpPr>
             <a:spLocks noGrp="1"/>
           </p:cNvSpPr>
@@ -371,7 +371,7 @@
       </p:sp>
       <p:sp>
         <p:nvSpPr>
-          <p:cNvPr id="847467478" name="Slide Number Placeholder 6"/>
+          <p:cNvPr id="2065725286" name="Slide Number Placeholder 6"/>
           <p:cNvSpPr>
             <a:spLocks noGrp="1"/>
           </p:cNvSpPr>
@@ -524,7 +524,7 @@
       </p:grpSpPr>
       <p:sp>
         <p:nvSpPr>
-          <p:cNvPr id="2" name="Slide Image Placeholder 1"/>
+          <p:cNvPr id="803818654" name="Slide Image Placeholder 1"/>
           <p:cNvSpPr>
             <a:spLocks noChangeAspect="1" noGrp="1" noRot="1"/>
           </p:cNvSpPr>
@@ -536,7 +536,7 @@
       </p:sp>
       <p:sp>
         <p:nvSpPr>
-          <p:cNvPr id="3" name="Notes Placeholder 2"/>
+          <p:cNvPr id="442833668" name="Notes Placeholder 2"/>
           <p:cNvSpPr>
             <a:spLocks noGrp="1"/>
           </p:cNvSpPr>
@@ -558,7 +558,7 @@
       </p:sp>
       <p:sp>
         <p:nvSpPr>
-          <p:cNvPr id="4" name="Slide Number Placeholder 3"/>
+          <p:cNvPr id="278852803" name="Slide Number Placeholder 3"/>
           <p:cNvSpPr>
             <a:spLocks noGrp="1"/>
           </p:cNvSpPr>
@@ -609,7 +609,7 @@
       </p:grpSpPr>
       <p:sp>
         <p:nvSpPr>
-          <p:cNvPr id="2" name="Slide Image Placeholder 1"/>
+          <p:cNvPr id="1149396300" name="Slide Image Placeholder 1"/>
           <p:cNvSpPr>
             <a:spLocks noChangeAspect="1" noGrp="1" noRot="1"/>
           </p:cNvSpPr>
@@ -621,7 +621,7 @@
       </p:sp>
       <p:sp>
         <p:nvSpPr>
-          <p:cNvPr id="3" name="Notes Placeholder 2"/>
+          <p:cNvPr id="2000738655" name="Notes Placeholder 2"/>
           <p:cNvSpPr>
             <a:spLocks noGrp="1"/>
           </p:cNvSpPr>
@@ -643,7 +643,7 @@
       </p:sp>
       <p:sp>
         <p:nvSpPr>
-          <p:cNvPr id="4" name="Slide Number Placeholder 3"/>
+          <p:cNvPr id="1880270304" name="Slide Number Placeholder 3"/>
           <p:cNvSpPr>
             <a:spLocks noGrp="1"/>
           </p:cNvSpPr>
@@ -694,7 +694,7 @@
       </p:grpSpPr>
       <p:sp>
         <p:nvSpPr>
-          <p:cNvPr id="2" name="Slide Image Placeholder 1"/>
+          <p:cNvPr id="1745395542" name="Slide Image Placeholder 1"/>
           <p:cNvSpPr>
             <a:spLocks noChangeAspect="1" noGrp="1" noRot="1"/>
           </p:cNvSpPr>
@@ -706,7 +706,7 @@
       </p:sp>
       <p:sp>
         <p:nvSpPr>
-          <p:cNvPr id="3" name="Notes Placeholder 2"/>
+          <p:cNvPr id="138235621" name="Notes Placeholder 2"/>
           <p:cNvSpPr>
             <a:spLocks noGrp="1"/>
           </p:cNvSpPr>
@@ -728,7 +728,7 @@
       </p:sp>
       <p:sp>
         <p:nvSpPr>
-          <p:cNvPr id="4" name="Slide Number Placeholder 3"/>
+          <p:cNvPr id="1680421019" name="Slide Number Placeholder 3"/>
           <p:cNvSpPr>
             <a:spLocks noGrp="1"/>
           </p:cNvSpPr>
@@ -779,7 +779,7 @@
       </p:grpSpPr>
       <p:sp>
         <p:nvSpPr>
-          <p:cNvPr id="2" name="Slide Image Placeholder 1"/>
+          <p:cNvPr id="1960826809" name="Slide Image Placeholder 1"/>
           <p:cNvSpPr>
             <a:spLocks noChangeAspect="1" noGrp="1" noRot="1"/>
           </p:cNvSpPr>
@@ -791,7 +791,7 @@
       </p:sp>
       <p:sp>
         <p:nvSpPr>
-          <p:cNvPr id="3" name="Notes Placeholder 2"/>
+          <p:cNvPr id="327965772" name="Notes Placeholder 2"/>
           <p:cNvSpPr>
             <a:spLocks noGrp="1"/>
           </p:cNvSpPr>
@@ -813,7 +813,7 @@
       </p:sp>
       <p:sp>
         <p:nvSpPr>
-          <p:cNvPr id="4" name="Slide Number Placeholder 3"/>
+          <p:cNvPr id="447895976" name="Slide Number Placeholder 3"/>
           <p:cNvSpPr>
             <a:spLocks noGrp="1"/>
           </p:cNvSpPr>
@@ -864,7 +864,7 @@
       </p:grpSpPr>
       <p:sp>
         <p:nvSpPr>
-          <p:cNvPr id="2" name="Slide Image Placeholder 1"/>
+          <p:cNvPr id="700515744" name="Slide Image Placeholder 1"/>
           <p:cNvSpPr>
             <a:spLocks noChangeAspect="1" noGrp="1" noRot="1"/>
           </p:cNvSpPr>
@@ -876,7 +876,7 @@
       </p:sp>
       <p:sp>
         <p:nvSpPr>
-          <p:cNvPr id="3" name="Notes Placeholder 2"/>
+          <p:cNvPr id="299916788" name="Notes Placeholder 2"/>
           <p:cNvSpPr>
             <a:spLocks noGrp="1"/>
           </p:cNvSpPr>
@@ -898,7 +898,7 @@
       </p:sp>
       <p:sp>
         <p:nvSpPr>
-          <p:cNvPr id="4" name="Slide Number Placeholder 3"/>
+          <p:cNvPr id="809017436" name="Slide Number Placeholder 3"/>
           <p:cNvSpPr>
             <a:spLocks noGrp="1"/>
           </p:cNvSpPr>
@@ -949,7 +949,7 @@
       </p:grpSpPr>
       <p:sp>
         <p:nvSpPr>
-          <p:cNvPr id="2" name="Slide Image Placeholder 1"/>
+          <p:cNvPr id="373427198" name="Slide Image Placeholder 1"/>
           <p:cNvSpPr>
             <a:spLocks noChangeAspect="1" noGrp="1" noRot="1"/>
           </p:cNvSpPr>
@@ -961,7 +961,7 @@
       </p:sp>
       <p:sp>
         <p:nvSpPr>
-          <p:cNvPr id="3" name="Notes Placeholder 2"/>
+          <p:cNvPr id="1780527406" name="Notes Placeholder 2"/>
           <p:cNvSpPr>
             <a:spLocks noGrp="1"/>
           </p:cNvSpPr>
@@ -983,7 +983,7 @@
       </p:sp>
       <p:sp>
         <p:nvSpPr>
-          <p:cNvPr id="4" name="Slide Number Placeholder 3"/>
+          <p:cNvPr id="1551331375" name="Slide Number Placeholder 3"/>
           <p:cNvSpPr>
             <a:spLocks noGrp="1"/>
           </p:cNvSpPr>
@@ -1034,7 +1034,7 @@
       </p:grpSpPr>
       <p:sp>
         <p:nvSpPr>
-          <p:cNvPr id="2" name="Slide Image Placeholder 1"/>
+          <p:cNvPr id="744684110" name="Slide Image Placeholder 1"/>
           <p:cNvSpPr>
             <a:spLocks noChangeAspect="1" noGrp="1" noRot="1"/>
           </p:cNvSpPr>
@@ -1046,7 +1046,7 @@
       </p:sp>
       <p:sp>
         <p:nvSpPr>
-          <p:cNvPr id="3" name="Notes Placeholder 2"/>
+          <p:cNvPr id="1983207577" name="Notes Placeholder 2"/>
           <p:cNvSpPr>
             <a:spLocks noGrp="1"/>
           </p:cNvSpPr>
@@ -1068,7 +1068,7 @@
       </p:sp>
       <p:sp>
         <p:nvSpPr>
-          <p:cNvPr id="4" name="Slide Number Placeholder 3"/>
+          <p:cNvPr id="1792820533" name="Slide Number Placeholder 3"/>
           <p:cNvSpPr>
             <a:spLocks noGrp="1"/>
           </p:cNvSpPr>
@@ -1119,7 +1119,7 @@
       </p:grpSpPr>
       <p:sp>
         <p:nvSpPr>
-          <p:cNvPr id="2" name="Slide Image Placeholder 1"/>
+          <p:cNvPr id="1765321928" name="Slide Image Placeholder 1"/>
           <p:cNvSpPr>
             <a:spLocks noChangeAspect="1" noGrp="1" noRot="1"/>
           </p:cNvSpPr>
@@ -1131,7 +1131,7 @@
       </p:sp>
       <p:sp>
         <p:nvSpPr>
-          <p:cNvPr id="3" name="Notes Placeholder 2"/>
+          <p:cNvPr id="1339118873" name="Notes Placeholder 2"/>
           <p:cNvSpPr>
             <a:spLocks noGrp="1"/>
           </p:cNvSpPr>
@@ -1153,7 +1153,7 @@
       </p:sp>
       <p:sp>
         <p:nvSpPr>
-          <p:cNvPr id="4" name="Slide Number Placeholder 3"/>
+          <p:cNvPr id="1877380827" name="Slide Number Placeholder 3"/>
           <p:cNvSpPr>
             <a:spLocks noGrp="1"/>
           </p:cNvSpPr>
@@ -1204,7 +1204,7 @@
       </p:grpSpPr>
       <p:sp>
         <p:nvSpPr>
-          <p:cNvPr id="2" name="Slide Image Placeholder 1"/>
+          <p:cNvPr id="1491705198" name="Slide Image Placeholder 1"/>
           <p:cNvSpPr>
             <a:spLocks noChangeAspect="1" noGrp="1" noRot="1"/>
           </p:cNvSpPr>
@@ -1216,7 +1216,7 @@
       </p:sp>
       <p:sp>
         <p:nvSpPr>
-          <p:cNvPr id="3" name="Notes Placeholder 2"/>
+          <p:cNvPr id="1877792647" name="Notes Placeholder 2"/>
           <p:cNvSpPr>
             <a:spLocks noGrp="1"/>
           </p:cNvSpPr>
@@ -1238,7 +1238,7 @@
       </p:sp>
       <p:sp>
         <p:nvSpPr>
-          <p:cNvPr id="4" name="Slide Number Placeholder 3"/>
+          <p:cNvPr id="498313195" name="Slide Number Placeholder 3"/>
           <p:cNvSpPr>
             <a:spLocks noGrp="1"/>
           </p:cNvSpPr>
@@ -1289,7 +1289,7 @@
       </p:grpSpPr>
       <p:sp>
         <p:nvSpPr>
-          <p:cNvPr id="2" name="Slide Image Placeholder 1"/>
+          <p:cNvPr id="192915709" name="Slide Image Placeholder 1"/>
           <p:cNvSpPr>
             <a:spLocks noChangeAspect="1" noGrp="1" noRot="1"/>
           </p:cNvSpPr>
@@ -1301,7 +1301,7 @@
       </p:sp>
       <p:sp>
         <p:nvSpPr>
-          <p:cNvPr id="3" name="Notes Placeholder 2"/>
+          <p:cNvPr id="581534368" name="Notes Placeholder 2"/>
           <p:cNvSpPr>
             <a:spLocks noGrp="1"/>
           </p:cNvSpPr>
@@ -1323,7 +1323,7 @@
       </p:sp>
       <p:sp>
         <p:nvSpPr>
-          <p:cNvPr id="4" name="Slide Number Placeholder 3"/>
+          <p:cNvPr id="27170978" name="Slide Number Placeholder 3"/>
           <p:cNvSpPr>
             <a:spLocks noGrp="1"/>
           </p:cNvSpPr>
@@ -1374,7 +1374,7 @@
       </p:grpSpPr>
       <p:sp>
         <p:nvSpPr>
-          <p:cNvPr id="2" name="Slide Image Placeholder 1"/>
+          <p:cNvPr id="1739261546" name="Slide Image Placeholder 1"/>
           <p:cNvSpPr>
             <a:spLocks noChangeAspect="1" noGrp="1" noRot="1"/>
           </p:cNvSpPr>
@@ -1386,7 +1386,7 @@
       </p:sp>
       <p:sp>
         <p:nvSpPr>
-          <p:cNvPr id="3" name="Notes Placeholder 2"/>
+          <p:cNvPr id="55570856" name="Notes Placeholder 2"/>
           <p:cNvSpPr>
             <a:spLocks noGrp="1"/>
           </p:cNvSpPr>
@@ -1408,7 +1408,7 @@
       </p:sp>
       <p:sp>
         <p:nvSpPr>
-          <p:cNvPr id="4" name="Slide Number Placeholder 3"/>
+          <p:cNvPr id="2083777559" name="Slide Number Placeholder 3"/>
           <p:cNvSpPr>
             <a:spLocks noGrp="1"/>
           </p:cNvSpPr>
@@ -1459,7 +1459,7 @@
       </p:grpSpPr>
       <p:sp>
         <p:nvSpPr>
-          <p:cNvPr id="2" name="Slide Image Placeholder 1"/>
+          <p:cNvPr id="1651673542" name="Slide Image Placeholder 1"/>
           <p:cNvSpPr>
             <a:spLocks noChangeAspect="1" noGrp="1" noRot="1"/>
           </p:cNvSpPr>
@@ -1471,7 +1471,7 @@
       </p:sp>
       <p:sp>
         <p:nvSpPr>
-          <p:cNvPr id="3" name="Notes Placeholder 2"/>
+          <p:cNvPr id="293494567" name="Notes Placeholder 2"/>
           <p:cNvSpPr>
             <a:spLocks noGrp="1"/>
           </p:cNvSpPr>
@@ -1493,7 +1493,7 @@
       </p:sp>
       <p:sp>
         <p:nvSpPr>
-          <p:cNvPr id="4" name="Slide Number Placeholder 3"/>
+          <p:cNvPr id="694698438" name="Slide Number Placeholder 3"/>
           <p:cNvSpPr>
             <a:spLocks noGrp="1"/>
           </p:cNvSpPr>
@@ -1544,7 +1544,7 @@
       </p:grpSpPr>
       <p:sp>
         <p:nvSpPr>
-          <p:cNvPr id="2045710364" name="Slide Image Placeholder 1"/>
+          <p:cNvPr id="544675133" name="Slide Image Placeholder 1"/>
           <p:cNvSpPr>
             <a:spLocks noChangeAspect="1" noGrp="1" noRot="1"/>
           </p:cNvSpPr>
@@ -1556,7 +1556,7 @@
       </p:sp>
       <p:sp>
         <p:nvSpPr>
-          <p:cNvPr id="2057927618" name="Notes Placeholder 2"/>
+          <p:cNvPr id="1226111352" name="Notes Placeholder 2"/>
           <p:cNvSpPr>
             <a:spLocks noGrp="1"/>
           </p:cNvSpPr>
@@ -1582,7 +1582,7 @@
       </p:sp>
       <p:sp>
         <p:nvSpPr>
-          <p:cNvPr id="1391457702" name="Slide Number Placeholder 3"/>
+          <p:cNvPr id="1982039702" name="Slide Number Placeholder 3"/>
           <p:cNvSpPr>
             <a:spLocks noGrp="1"/>
           </p:cNvSpPr>
@@ -1633,7 +1633,7 @@
       </p:grpSpPr>
       <p:sp>
         <p:nvSpPr>
-          <p:cNvPr id="2" name="Slide Image Placeholder 1"/>
+          <p:cNvPr id="1486175078" name="Slide Image Placeholder 1"/>
           <p:cNvSpPr>
             <a:spLocks noChangeAspect="1" noGrp="1" noRot="1"/>
           </p:cNvSpPr>
@@ -1645,7 +1645,7 @@
       </p:sp>
       <p:sp>
         <p:nvSpPr>
-          <p:cNvPr id="3" name="Notes Placeholder 2"/>
+          <p:cNvPr id="353404172" name="Notes Placeholder 2"/>
           <p:cNvSpPr>
             <a:spLocks noGrp="1"/>
           </p:cNvSpPr>
@@ -1667,7 +1667,7 @@
       </p:sp>
       <p:sp>
         <p:nvSpPr>
-          <p:cNvPr id="4" name="Slide Number Placeholder 3"/>
+          <p:cNvPr id="266393379" name="Slide Number Placeholder 3"/>
           <p:cNvSpPr>
             <a:spLocks noGrp="1"/>
           </p:cNvSpPr>
@@ -1718,7 +1718,7 @@
       </p:grpSpPr>
       <p:sp>
         <p:nvSpPr>
-          <p:cNvPr id="2" name="Slide Image Placeholder 1"/>
+          <p:cNvPr id="1030383532" name="Slide Image Placeholder 1"/>
           <p:cNvSpPr>
             <a:spLocks noChangeAspect="1" noGrp="1" noRot="1"/>
           </p:cNvSpPr>
@@ -1730,7 +1730,7 @@
       </p:sp>
       <p:sp>
         <p:nvSpPr>
-          <p:cNvPr id="3" name="Notes Placeholder 2"/>
+          <p:cNvPr id="198766586" name="Notes Placeholder 2"/>
           <p:cNvSpPr>
             <a:spLocks noGrp="1"/>
           </p:cNvSpPr>
@@ -1752,7 +1752,7 @@
       </p:sp>
       <p:sp>
         <p:nvSpPr>
-          <p:cNvPr id="4" name="Slide Number Placeholder 3"/>
+          <p:cNvPr id="1650605725" name="Slide Number Placeholder 3"/>
           <p:cNvSpPr>
             <a:spLocks noGrp="1"/>
           </p:cNvSpPr>
@@ -1803,7 +1803,7 @@
       </p:grpSpPr>
       <p:sp>
         <p:nvSpPr>
-          <p:cNvPr id="2" name="Slide Image Placeholder 1"/>
+          <p:cNvPr id="503044987" name="Slide Image Placeholder 1"/>
           <p:cNvSpPr>
             <a:spLocks noChangeAspect="1" noGrp="1" noRot="1"/>
           </p:cNvSpPr>
@@ -1815,7 +1815,7 @@
       </p:sp>
       <p:sp>
         <p:nvSpPr>
-          <p:cNvPr id="3" name="Notes Placeholder 2"/>
+          <p:cNvPr id="111259673" name="Notes Placeholder 2"/>
           <p:cNvSpPr>
             <a:spLocks noGrp="1"/>
           </p:cNvSpPr>
@@ -1837,7 +1837,7 @@
       </p:sp>
       <p:sp>
         <p:nvSpPr>
-          <p:cNvPr id="4" name="Slide Number Placeholder 3"/>
+          <p:cNvPr id="234327984" name="Slide Number Placeholder 3"/>
           <p:cNvSpPr>
             <a:spLocks noGrp="1"/>
           </p:cNvSpPr>
@@ -1888,7 +1888,7 @@
       </p:grpSpPr>
       <p:sp>
         <p:nvSpPr>
-          <p:cNvPr id="2" name="Slide Image Placeholder 1"/>
+          <p:cNvPr id="699188550" name="Slide Image Placeholder 1"/>
           <p:cNvSpPr>
             <a:spLocks noChangeAspect="1" noGrp="1" noRot="1"/>
           </p:cNvSpPr>
@@ -1900,7 +1900,7 @@
       </p:sp>
       <p:sp>
         <p:nvSpPr>
-          <p:cNvPr id="3" name="Notes Placeholder 2"/>
+          <p:cNvPr id="256141640" name="Notes Placeholder 2"/>
           <p:cNvSpPr>
             <a:spLocks noGrp="1"/>
           </p:cNvSpPr>
@@ -1922,7 +1922,7 @@
       </p:sp>
       <p:sp>
         <p:nvSpPr>
-          <p:cNvPr id="4" name="Slide Number Placeholder 3"/>
+          <p:cNvPr id="1395103804" name="Slide Number Placeholder 3"/>
           <p:cNvSpPr>
             <a:spLocks noGrp="1"/>
           </p:cNvSpPr>
@@ -1973,7 +1973,7 @@
       </p:grpSpPr>
       <p:sp>
         <p:nvSpPr>
-          <p:cNvPr id="2" name="Slide Image Placeholder 1"/>
+          <p:cNvPr id="376070266" name="Slide Image Placeholder 1"/>
           <p:cNvSpPr>
             <a:spLocks noChangeAspect="1" noGrp="1" noRot="1"/>
           </p:cNvSpPr>
@@ -1985,7 +1985,7 @@
       </p:sp>
       <p:sp>
         <p:nvSpPr>
-          <p:cNvPr id="3" name="Notes Placeholder 2"/>
+          <p:cNvPr id="90571872" name="Notes Placeholder 2"/>
           <p:cNvSpPr>
             <a:spLocks noGrp="1"/>
           </p:cNvSpPr>
@@ -2007,7 +2007,7 @@
       </p:sp>
       <p:sp>
         <p:nvSpPr>
-          <p:cNvPr id="4" name="Slide Number Placeholder 3"/>
+          <p:cNvPr id="1356215852" name="Slide Number Placeholder 3"/>
           <p:cNvSpPr>
             <a:spLocks noGrp="1"/>
           </p:cNvSpPr>
@@ -2058,7 +2058,7 @@
       </p:grpSpPr>
       <p:sp>
         <p:nvSpPr>
-          <p:cNvPr id="2" name="Slide Image Placeholder 1"/>
+          <p:cNvPr id="739109897" name="Slide Image Placeholder 1"/>
           <p:cNvSpPr>
             <a:spLocks noChangeAspect="1" noGrp="1" noRot="1"/>
           </p:cNvSpPr>
@@ -2070,7 +2070,7 @@
       </p:sp>
       <p:sp>
         <p:nvSpPr>
-          <p:cNvPr id="3" name="Notes Placeholder 2"/>
+          <p:cNvPr id="1630118032" name="Notes Placeholder 2"/>
           <p:cNvSpPr>
             <a:spLocks noGrp="1"/>
           </p:cNvSpPr>
@@ -2092,7 +2092,7 @@
       </p:sp>
       <p:sp>
         <p:nvSpPr>
-          <p:cNvPr id="4" name="Slide Number Placeholder 3"/>
+          <p:cNvPr id="711051287" name="Slide Number Placeholder 3"/>
           <p:cNvSpPr>
             <a:spLocks noGrp="1"/>
           </p:cNvSpPr>
@@ -2143,7 +2143,7 @@
       </p:grpSpPr>
       <p:sp>
         <p:nvSpPr>
-          <p:cNvPr id="2" name="Slide Image Placeholder 1"/>
+          <p:cNvPr id="413435766" name="Slide Image Placeholder 1"/>
           <p:cNvSpPr>
             <a:spLocks noChangeAspect="1" noGrp="1" noRot="1"/>
           </p:cNvSpPr>
@@ -2155,7 +2155,7 @@
       </p:sp>
       <p:sp>
         <p:nvSpPr>
-          <p:cNvPr id="3" name="Notes Placeholder 2"/>
+          <p:cNvPr id="1075370002" name="Notes Placeholder 2"/>
           <p:cNvSpPr>
             <a:spLocks noGrp="1"/>
           </p:cNvSpPr>
@@ -2177,7 +2177,7 @@
       </p:sp>
       <p:sp>
         <p:nvSpPr>
-          <p:cNvPr id="4" name="Slide Number Placeholder 3"/>
+          <p:cNvPr id="449256693" name="Slide Number Placeholder 3"/>
           <p:cNvSpPr>
             <a:spLocks noGrp="1"/>
           </p:cNvSpPr>
@@ -2228,7 +2228,7 @@
       </p:grpSpPr>
       <p:sp>
         <p:nvSpPr>
-          <p:cNvPr id="2" name="Slide Image Placeholder 1"/>
+          <p:cNvPr id="1192872622" name="Slide Image Placeholder 1"/>
           <p:cNvSpPr>
             <a:spLocks noChangeAspect="1" noGrp="1" noRot="1"/>
           </p:cNvSpPr>
@@ -2240,7 +2240,7 @@
       </p:sp>
       <p:sp>
         <p:nvSpPr>
-          <p:cNvPr id="3" name="Notes Placeholder 2"/>
+          <p:cNvPr id="1638476318" name="Notes Placeholder 2"/>
           <p:cNvSpPr>
             <a:spLocks noGrp="1"/>
           </p:cNvSpPr>
@@ -2262,7 +2262,7 @@
       </p:sp>
       <p:sp>
         <p:nvSpPr>
-          <p:cNvPr id="4" name="Slide Number Placeholder 3"/>
+          <p:cNvPr id="31868835" name="Slide Number Placeholder 3"/>
           <p:cNvSpPr>
             <a:spLocks noGrp="1"/>
           </p:cNvSpPr>
@@ -2313,7 +2313,7 @@
       </p:grpSpPr>
       <p:sp>
         <p:nvSpPr>
-          <p:cNvPr id="2" name="Slide Image Placeholder 1"/>
+          <p:cNvPr id="468932376" name="Slide Image Placeholder 1"/>
           <p:cNvSpPr>
             <a:spLocks noChangeAspect="1" noGrp="1" noRot="1"/>
           </p:cNvSpPr>
@@ -2325,7 +2325,7 @@
       </p:sp>
       <p:sp>
         <p:nvSpPr>
-          <p:cNvPr id="3" name="Notes Placeholder 2"/>
+          <p:cNvPr id="495035639" name="Notes Placeholder 2"/>
           <p:cNvSpPr>
             <a:spLocks noGrp="1"/>
           </p:cNvSpPr>
@@ -2347,7 +2347,7 @@
       </p:sp>
       <p:sp>
         <p:nvSpPr>
-          <p:cNvPr id="4" name="Slide Number Placeholder 3"/>
+          <p:cNvPr id="486478839" name="Slide Number Placeholder 3"/>
           <p:cNvSpPr>
             <a:spLocks noGrp="1"/>
           </p:cNvSpPr>
@@ -2398,7 +2398,7 @@
       </p:grpSpPr>
       <p:sp>
         <p:nvSpPr>
-          <p:cNvPr id="1054929923" name="Title 1"/>
+          <p:cNvPr id="1976162825" name="Title 1"/>
           <p:cNvSpPr>
             <a:spLocks noGrp="1"/>
           </p:cNvSpPr>
@@ -2433,7 +2433,7 @@
       </p:sp>
       <p:sp>
         <p:nvSpPr>
-          <p:cNvPr id="1759389023" name="Subtitle 2"/>
+          <p:cNvPr id="862713879" name="Subtitle 2"/>
           <p:cNvSpPr>
             <a:spLocks noGrp="1"/>
           </p:cNvSpPr>
@@ -2501,7 +2501,7 @@
       </p:sp>
       <p:sp>
         <p:nvSpPr>
-          <p:cNvPr id="106757784" name="Date Placeholder 3"/>
+          <p:cNvPr id="2030700438" name="Date Placeholder 3"/>
           <p:cNvSpPr>
             <a:spLocks noGrp="1"/>
           </p:cNvSpPr>
@@ -2527,7 +2527,7 @@
       </p:sp>
       <p:sp>
         <p:nvSpPr>
-          <p:cNvPr id="2134904481" name="Footer Placeholder 4"/>
+          <p:cNvPr id="442208636" name="Footer Placeholder 4"/>
           <p:cNvSpPr>
             <a:spLocks noGrp="1"/>
           </p:cNvSpPr>
@@ -2549,7 +2549,7 @@
       </p:sp>
       <p:sp>
         <p:nvSpPr>
-          <p:cNvPr id="854171669" name="Slide Number Placeholder 5"/>
+          <p:cNvPr id="1801474599" name="Slide Number Placeholder 5"/>
           <p:cNvSpPr>
             <a:spLocks noGrp="1"/>
           </p:cNvSpPr>
@@ -2600,7 +2600,7 @@
       </p:grpSpPr>
       <p:sp>
         <p:nvSpPr>
-          <p:cNvPr id="191038040" name="Title 1"/>
+          <p:cNvPr id="1206918325" name="Title 1"/>
           <p:cNvSpPr>
             <a:spLocks noGrp="1"/>
           </p:cNvSpPr>
@@ -2626,7 +2626,7 @@
       </p:sp>
       <p:sp>
         <p:nvSpPr>
-          <p:cNvPr id="785869009" name="Vertical Text Placeholder 2"/>
+          <p:cNvPr id="28830713" name="Vertical Text Placeholder 2"/>
           <p:cNvSpPr>
             <a:spLocks noGrp="1"/>
           </p:cNvSpPr>
@@ -2692,7 +2692,7 @@
       </p:sp>
       <p:sp>
         <p:nvSpPr>
-          <p:cNvPr id="2064374710" name="Date Placeholder 3"/>
+          <p:cNvPr id="1365922323" name="Date Placeholder 3"/>
           <p:cNvSpPr>
             <a:spLocks noGrp="1"/>
           </p:cNvSpPr>
@@ -2718,7 +2718,7 @@
       </p:sp>
       <p:sp>
         <p:nvSpPr>
-          <p:cNvPr id="191736323" name="Footer Placeholder 4"/>
+          <p:cNvPr id="1828749181" name="Footer Placeholder 4"/>
           <p:cNvSpPr>
             <a:spLocks noGrp="1"/>
           </p:cNvSpPr>
@@ -2740,7 +2740,7 @@
       </p:sp>
       <p:sp>
         <p:nvSpPr>
-          <p:cNvPr id="947797890" name="Slide Number Placeholder 5"/>
+          <p:cNvPr id="1755242018" name="Slide Number Placeholder 5"/>
           <p:cNvSpPr>
             <a:spLocks noGrp="1"/>
           </p:cNvSpPr>
@@ -2791,7 +2791,7 @@
       </p:grpSpPr>
       <p:sp>
         <p:nvSpPr>
-          <p:cNvPr id="224080065" name="Vertical Title 1"/>
+          <p:cNvPr id="1518670892" name="Vertical Title 1"/>
           <p:cNvSpPr>
             <a:spLocks noGrp="1"/>
           </p:cNvSpPr>
@@ -2822,7 +2822,7 @@
       </p:sp>
       <p:sp>
         <p:nvSpPr>
-          <p:cNvPr id="677642943" name="Vertical Text Placeholder 2"/>
+          <p:cNvPr id="1430701194" name="Vertical Text Placeholder 2"/>
           <p:cNvSpPr>
             <a:spLocks noGrp="1"/>
           </p:cNvSpPr>
@@ -2893,7 +2893,7 @@
       </p:sp>
       <p:sp>
         <p:nvSpPr>
-          <p:cNvPr id="888631389" name="Date Placeholder 3"/>
+          <p:cNvPr id="1152652994" name="Date Placeholder 3"/>
           <p:cNvSpPr>
             <a:spLocks noGrp="1"/>
           </p:cNvSpPr>
@@ -2919,7 +2919,7 @@
       </p:sp>
       <p:sp>
         <p:nvSpPr>
-          <p:cNvPr id="571011979" name="Footer Placeholder 4"/>
+          <p:cNvPr id="2047660373" name="Footer Placeholder 4"/>
           <p:cNvSpPr>
             <a:spLocks noGrp="1"/>
           </p:cNvSpPr>
@@ -2941,7 +2941,7 @@
       </p:sp>
       <p:sp>
         <p:nvSpPr>
-          <p:cNvPr id="1604807802" name="Slide Number Placeholder 5"/>
+          <p:cNvPr id="482359844" name="Slide Number Placeholder 5"/>
           <p:cNvSpPr>
             <a:spLocks noGrp="1"/>
           </p:cNvSpPr>
@@ -2992,7 +2992,7 @@
       </p:grpSpPr>
       <p:sp>
         <p:nvSpPr>
-          <p:cNvPr id="1170771761" name="Title 1"/>
+          <p:cNvPr id="936521288" name="Title 1"/>
           <p:cNvSpPr>
             <a:spLocks noGrp="1"/>
           </p:cNvSpPr>
@@ -3018,7 +3018,7 @@
       </p:sp>
       <p:sp>
         <p:nvSpPr>
-          <p:cNvPr id="647286988" name="Content Placeholder 2"/>
+          <p:cNvPr id="1421599640" name="Content Placeholder 2"/>
           <p:cNvSpPr>
             <a:spLocks noGrp="1"/>
           </p:cNvSpPr>
@@ -3084,7 +3084,7 @@
       </p:sp>
       <p:sp>
         <p:nvSpPr>
-          <p:cNvPr id="699813286" name="Date Placeholder 3"/>
+          <p:cNvPr id="493695801" name="Date Placeholder 3"/>
           <p:cNvSpPr>
             <a:spLocks noGrp="1"/>
           </p:cNvSpPr>
@@ -3110,7 +3110,7 @@
       </p:sp>
       <p:sp>
         <p:nvSpPr>
-          <p:cNvPr id="1573584184" name="Footer Placeholder 4"/>
+          <p:cNvPr id="244354652" name="Footer Placeholder 4"/>
           <p:cNvSpPr>
             <a:spLocks noGrp="1"/>
           </p:cNvSpPr>
@@ -3132,7 +3132,7 @@
       </p:sp>
       <p:sp>
         <p:nvSpPr>
-          <p:cNvPr id="224620371" name="Slide Number Placeholder 5"/>
+          <p:cNvPr id="838021212" name="Slide Number Placeholder 5"/>
           <p:cNvSpPr>
             <a:spLocks noGrp="1"/>
           </p:cNvSpPr>
@@ -3183,7 +3183,7 @@
       </p:grpSpPr>
       <p:sp>
         <p:nvSpPr>
-          <p:cNvPr id="1938448652" name="Title 1"/>
+          <p:cNvPr id="600079877" name="Title 1"/>
           <p:cNvSpPr>
             <a:spLocks noGrp="1"/>
           </p:cNvSpPr>
@@ -3218,7 +3218,7 @@
       </p:sp>
       <p:sp>
         <p:nvSpPr>
-          <p:cNvPr id="2023355450" name="Text Placeholder 2"/>
+          <p:cNvPr id="1525060195" name="Text Placeholder 2"/>
           <p:cNvSpPr>
             <a:spLocks noGrp="1"/>
           </p:cNvSpPr>
@@ -3340,7 +3340,7 @@
       </p:sp>
       <p:sp>
         <p:nvSpPr>
-          <p:cNvPr id="1422733523" name="Date Placeholder 3"/>
+          <p:cNvPr id="1540119542" name="Date Placeholder 3"/>
           <p:cNvSpPr>
             <a:spLocks noGrp="1"/>
           </p:cNvSpPr>
@@ -3366,7 +3366,7 @@
       </p:sp>
       <p:sp>
         <p:nvSpPr>
-          <p:cNvPr id="431785073" name="Footer Placeholder 4"/>
+          <p:cNvPr id="2135303219" name="Footer Placeholder 4"/>
           <p:cNvSpPr>
             <a:spLocks noGrp="1"/>
           </p:cNvSpPr>
@@ -3388,7 +3388,7 @@
       </p:sp>
       <p:sp>
         <p:nvSpPr>
-          <p:cNvPr id="420617121" name="Slide Number Placeholder 5"/>
+          <p:cNvPr id="1631998418" name="Slide Number Placeholder 5"/>
           <p:cNvSpPr>
             <a:spLocks noGrp="1"/>
           </p:cNvSpPr>
@@ -3439,7 +3439,7 @@
       </p:grpSpPr>
       <p:sp>
         <p:nvSpPr>
-          <p:cNvPr id="543185278" name="Title 1"/>
+          <p:cNvPr id="1738031112" name="Title 1"/>
           <p:cNvSpPr>
             <a:spLocks noGrp="1"/>
           </p:cNvSpPr>
@@ -3465,7 +3465,7 @@
       </p:sp>
       <p:sp>
         <p:nvSpPr>
-          <p:cNvPr id="2059999756" name="Content Placeholder 2"/>
+          <p:cNvPr id="1548767299" name="Content Placeholder 2"/>
           <p:cNvSpPr>
             <a:spLocks noGrp="1"/>
           </p:cNvSpPr>
@@ -3536,7 +3536,7 @@
       </p:sp>
       <p:sp>
         <p:nvSpPr>
-          <p:cNvPr id="1217684751" name="Content Placeholder 3"/>
+          <p:cNvPr id="388747444" name="Content Placeholder 3"/>
           <p:cNvSpPr>
             <a:spLocks noGrp="1"/>
           </p:cNvSpPr>
@@ -3607,7 +3607,7 @@
       </p:sp>
       <p:sp>
         <p:nvSpPr>
-          <p:cNvPr id="1548675672" name="Date Placeholder 4"/>
+          <p:cNvPr id="1146114258" name="Date Placeholder 4"/>
           <p:cNvSpPr>
             <a:spLocks noGrp="1"/>
           </p:cNvSpPr>
@@ -3633,7 +3633,7 @@
       </p:sp>
       <p:sp>
         <p:nvSpPr>
-          <p:cNvPr id="1200965014" name="Footer Placeholder 5"/>
+          <p:cNvPr id="1327283016" name="Footer Placeholder 5"/>
           <p:cNvSpPr>
             <a:spLocks noGrp="1"/>
           </p:cNvSpPr>
@@ -3655,7 +3655,7 @@
       </p:sp>
       <p:sp>
         <p:nvSpPr>
-          <p:cNvPr id="242772628" name="Slide Number Placeholder 6"/>
+          <p:cNvPr id="390894495" name="Slide Number Placeholder 6"/>
           <p:cNvSpPr>
             <a:spLocks noGrp="1"/>
           </p:cNvSpPr>
@@ -3706,7 +3706,7 @@
       </p:grpSpPr>
       <p:sp>
         <p:nvSpPr>
-          <p:cNvPr id="1461304707" name="Title 1"/>
+          <p:cNvPr id="818617998" name="Title 1"/>
           <p:cNvSpPr>
             <a:spLocks noGrp="1"/>
           </p:cNvSpPr>
@@ -3737,7 +3737,7 @@
       </p:sp>
       <p:sp>
         <p:nvSpPr>
-          <p:cNvPr id="347055316" name="Text Placeholder 2"/>
+          <p:cNvPr id="1017228474" name="Text Placeholder 2"/>
           <p:cNvSpPr>
             <a:spLocks noGrp="1"/>
           </p:cNvSpPr>
@@ -3805,7 +3805,7 @@
       </p:sp>
       <p:sp>
         <p:nvSpPr>
-          <p:cNvPr id="1848600112" name="Content Placeholder 3"/>
+          <p:cNvPr id="1320024084" name="Content Placeholder 3"/>
           <p:cNvSpPr>
             <a:spLocks noGrp="1"/>
           </p:cNvSpPr>
@@ -3876,7 +3876,7 @@
       </p:sp>
       <p:sp>
         <p:nvSpPr>
-          <p:cNvPr id="2030352633" name="Text Placeholder 4"/>
+          <p:cNvPr id="1356382840" name="Text Placeholder 4"/>
           <p:cNvSpPr>
             <a:spLocks noGrp="1"/>
           </p:cNvSpPr>
@@ -3944,7 +3944,7 @@
       </p:sp>
       <p:sp>
         <p:nvSpPr>
-          <p:cNvPr id="868255558" name="Content Placeholder 5"/>
+          <p:cNvPr id="1220400975" name="Content Placeholder 5"/>
           <p:cNvSpPr>
             <a:spLocks noGrp="1"/>
           </p:cNvSpPr>
@@ -4015,7 +4015,7 @@
       </p:sp>
       <p:sp>
         <p:nvSpPr>
-          <p:cNvPr id="1550814265" name="Date Placeholder 6"/>
+          <p:cNvPr id="1010161231" name="Date Placeholder 6"/>
           <p:cNvSpPr>
             <a:spLocks noGrp="1"/>
           </p:cNvSpPr>
@@ -4041,7 +4041,7 @@
       </p:sp>
       <p:sp>
         <p:nvSpPr>
-          <p:cNvPr id="249597770" name="Footer Placeholder 7"/>
+          <p:cNvPr id="1466435579" name="Footer Placeholder 7"/>
           <p:cNvSpPr>
             <a:spLocks noGrp="1"/>
           </p:cNvSpPr>
@@ -4063,7 +4063,7 @@
       </p:sp>
       <p:sp>
         <p:nvSpPr>
-          <p:cNvPr id="1276879765" name="Slide Number Placeholder 8"/>
+          <p:cNvPr id="405766150" name="Slide Number Placeholder 8"/>
           <p:cNvSpPr>
             <a:spLocks noGrp="1"/>
           </p:cNvSpPr>
@@ -4114,7 +4114,7 @@
       </p:grpSpPr>
       <p:sp>
         <p:nvSpPr>
-          <p:cNvPr id="128638979" name="Title 1"/>
+          <p:cNvPr id="783866553" name="Title 1"/>
           <p:cNvSpPr>
             <a:spLocks noGrp="1"/>
           </p:cNvSpPr>
@@ -4140,7 +4140,7 @@
       </p:sp>
       <p:sp>
         <p:nvSpPr>
-          <p:cNvPr id="357957667" name="Date Placeholder 2"/>
+          <p:cNvPr id="1739575651" name="Date Placeholder 2"/>
           <p:cNvSpPr>
             <a:spLocks noGrp="1"/>
           </p:cNvSpPr>
@@ -4166,7 +4166,7 @@
       </p:sp>
       <p:sp>
         <p:nvSpPr>
-          <p:cNvPr id="2105106674" name="Footer Placeholder 3"/>
+          <p:cNvPr id="826202579" name="Footer Placeholder 3"/>
           <p:cNvSpPr>
             <a:spLocks noGrp="1"/>
           </p:cNvSpPr>
@@ -4188,7 +4188,7 @@
       </p:sp>
       <p:sp>
         <p:nvSpPr>
-          <p:cNvPr id="1129731976" name="Slide Number Placeholder 4"/>
+          <p:cNvPr id="1943718054" name="Slide Number Placeholder 4"/>
           <p:cNvSpPr>
             <a:spLocks noGrp="1"/>
           </p:cNvSpPr>
@@ -4239,7 +4239,7 @@
       </p:grpSpPr>
       <p:sp>
         <p:nvSpPr>
-          <p:cNvPr id="284406047" name="Date Placeholder 1"/>
+          <p:cNvPr id="1269508793" name="Date Placeholder 1"/>
           <p:cNvSpPr>
             <a:spLocks noGrp="1"/>
           </p:cNvSpPr>
@@ -4265,7 +4265,7 @@
       </p:sp>
       <p:sp>
         <p:nvSpPr>
-          <p:cNvPr id="1508342643" name="Footer Placeholder 2"/>
+          <p:cNvPr id="311842006" name="Footer Placeholder 2"/>
           <p:cNvSpPr>
             <a:spLocks noGrp="1"/>
           </p:cNvSpPr>
@@ -4287,7 +4287,7 @@
       </p:sp>
       <p:sp>
         <p:nvSpPr>
-          <p:cNvPr id="1673168124" name="Slide Number Placeholder 3"/>
+          <p:cNvPr id="225579245" name="Slide Number Placeholder 3"/>
           <p:cNvSpPr>
             <a:spLocks noGrp="1"/>
           </p:cNvSpPr>
@@ -4338,7 +4338,7 @@
       </p:grpSpPr>
       <p:sp>
         <p:nvSpPr>
-          <p:cNvPr id="545971187" name="Title 1"/>
+          <p:cNvPr id="1569017608" name="Title 1"/>
           <p:cNvSpPr>
             <a:spLocks noGrp="1"/>
           </p:cNvSpPr>
@@ -4373,7 +4373,7 @@
       </p:sp>
       <p:sp>
         <p:nvSpPr>
-          <p:cNvPr id="816657952" name="Content Placeholder 2"/>
+          <p:cNvPr id="290655935" name="Content Placeholder 2"/>
           <p:cNvSpPr>
             <a:spLocks noGrp="1"/>
           </p:cNvSpPr>
@@ -4472,7 +4472,7 @@
       </p:sp>
       <p:sp>
         <p:nvSpPr>
-          <p:cNvPr id="1829169159" name="Text Placeholder 3"/>
+          <p:cNvPr id="1906544737" name="Text Placeholder 3"/>
           <p:cNvSpPr>
             <a:spLocks noGrp="1"/>
           </p:cNvSpPr>
@@ -4540,7 +4540,7 @@
       </p:sp>
       <p:sp>
         <p:nvSpPr>
-          <p:cNvPr id="689204885" name="Date Placeholder 4"/>
+          <p:cNvPr id="409830365" name="Date Placeholder 4"/>
           <p:cNvSpPr>
             <a:spLocks noGrp="1"/>
           </p:cNvSpPr>
@@ -4566,7 +4566,7 @@
       </p:sp>
       <p:sp>
         <p:nvSpPr>
-          <p:cNvPr id="1957504130" name="Footer Placeholder 5"/>
+          <p:cNvPr id="639838551" name="Footer Placeholder 5"/>
           <p:cNvSpPr>
             <a:spLocks noGrp="1"/>
           </p:cNvSpPr>
@@ -4588,7 +4588,7 @@
       </p:sp>
       <p:sp>
         <p:nvSpPr>
-          <p:cNvPr id="552025729" name="Slide Number Placeholder 6"/>
+          <p:cNvPr id="949807425" name="Slide Number Placeholder 6"/>
           <p:cNvSpPr>
             <a:spLocks noGrp="1"/>
           </p:cNvSpPr>
@@ -4639,7 +4639,7 @@
       </p:grpSpPr>
       <p:sp>
         <p:nvSpPr>
-          <p:cNvPr id="769064104" name="Title 1"/>
+          <p:cNvPr id="1596300574" name="Title 1"/>
           <p:cNvSpPr>
             <a:spLocks noGrp="1"/>
           </p:cNvSpPr>
@@ -4674,7 +4674,7 @@
       </p:sp>
       <p:sp>
         <p:nvSpPr>
-          <p:cNvPr id="1053162174" name="Picture Placeholder 2"/>
+          <p:cNvPr id="484556533" name="Picture Placeholder 2"/>
           <p:cNvSpPr>
             <a:spLocks noGrp="1"/>
           </p:cNvSpPr>
@@ -4738,7 +4738,7 @@
       </p:sp>
       <p:sp>
         <p:nvSpPr>
-          <p:cNvPr id="312201547" name="Text Placeholder 3"/>
+          <p:cNvPr id="2052329778" name="Text Placeholder 3"/>
           <p:cNvSpPr>
             <a:spLocks noGrp="1"/>
           </p:cNvSpPr>
@@ -4806,7 +4806,7 @@
       </p:sp>
       <p:sp>
         <p:nvSpPr>
-          <p:cNvPr id="1102432438" name="Date Placeholder 4"/>
+          <p:cNvPr id="2073644113" name="Date Placeholder 4"/>
           <p:cNvSpPr>
             <a:spLocks noGrp="1"/>
           </p:cNvSpPr>
@@ -4832,7 +4832,7 @@
       </p:sp>
       <p:sp>
         <p:nvSpPr>
-          <p:cNvPr id="1275730566" name="Footer Placeholder 5"/>
+          <p:cNvPr id="970344542" name="Footer Placeholder 5"/>
           <p:cNvSpPr>
             <a:spLocks noGrp="1"/>
           </p:cNvSpPr>
@@ -4854,7 +4854,7 @@
       </p:sp>
       <p:sp>
         <p:nvSpPr>
-          <p:cNvPr id="382164618" name="Slide Number Placeholder 6"/>
+          <p:cNvPr id="1560357401" name="Slide Number Placeholder 6"/>
           <p:cNvSpPr>
             <a:spLocks noGrp="1"/>
           </p:cNvSpPr>
@@ -4910,7 +4910,7 @@
       </p:grpSpPr>
       <p:sp>
         <p:nvSpPr>
-          <p:cNvPr id="1072114418" name="Title Placeholder 1"/>
+          <p:cNvPr id="1852427976" name="Title Placeholder 1"/>
           <p:cNvSpPr>
             <a:spLocks noGrp="1"/>
           </p:cNvSpPr>
@@ -4946,7 +4946,7 @@
       </p:sp>
       <p:sp>
         <p:nvSpPr>
-          <p:cNvPr id="1794140653" name="Text Placeholder 2"/>
+          <p:cNvPr id="897132780" name="Text Placeholder 2"/>
           <p:cNvSpPr>
             <a:spLocks noGrp="1"/>
           </p:cNvSpPr>
@@ -5022,7 +5022,7 @@
       </p:sp>
       <p:sp>
         <p:nvSpPr>
-          <p:cNvPr id="320051945" name="Date Placeholder 3"/>
+          <p:cNvPr id="257144961" name="Date Placeholder 3"/>
           <p:cNvSpPr>
             <a:spLocks noGrp="1"/>
           </p:cNvSpPr>
@@ -5066,7 +5066,7 @@
       </p:sp>
       <p:sp>
         <p:nvSpPr>
-          <p:cNvPr id="2084706297" name="Footer Placeholder 4"/>
+          <p:cNvPr id="1603630589" name="Footer Placeholder 4"/>
           <p:cNvSpPr>
             <a:spLocks noGrp="1"/>
           </p:cNvSpPr>
@@ -5106,7 +5106,7 @@
       </p:sp>
       <p:sp>
         <p:nvSpPr>
-          <p:cNvPr id="676151130" name="Slide Number Placeholder 5"/>
+          <p:cNvPr id="1746496171" name="Slide Number Placeholder 5"/>
           <p:cNvSpPr>
             <a:spLocks noGrp="1"/>
           </p:cNvSpPr>
@@ -5467,7 +5467,7 @@
       </p:grpSpPr>
       <p:sp>
         <p:nvSpPr>
-          <p:cNvPr id="203136638" name="Title 1"/>
+          <p:cNvPr id="1680210033" name="Title 1"/>
           <p:cNvSpPr>
             <a:spLocks noGrp="1"/>
           </p:cNvSpPr>
@@ -5516,7 +5516,7 @@
       </p:sp>
       <p:sp>
         <p:nvSpPr>
-          <p:cNvPr id="938097126" name="Subtitle 2"/>
+          <p:cNvPr id="2027665133" name="Subtitle 2"/>
           <p:cNvSpPr>
             <a:spLocks noGrp="1"/>
           </p:cNvSpPr>
@@ -5544,19 +5544,6 @@
                 <a:latin typeface="Arial"/>
                 <a:cs typeface="Arial"/>
               </a:rPr>
-              <a:t>Micah Kruser, NW Energy Coalition</a:t>
-            </a:r>
-            <a:endParaRPr/>
-          </a:p>
-          <a:p>
-            <a:pPr>
-              <a:defRPr/>
-            </a:pPr>
-            <a:r>
-              <a:rPr lang="en-US">
-                <a:latin typeface="Arial"/>
-                <a:cs typeface="Arial"/>
-              </a:rPr>
               <a:t>Charlee Thompson, NW Energy Coalition</a:t>
             </a:r>
             <a:endParaRPr/>
@@ -5565,7 +5552,7 @@
       </p:sp>
       <p:sp>
         <p:nvSpPr>
-          <p:cNvPr id="471566453" name="Slide Number Placeholder 3"/>
+          <p:cNvPr id="36780429" name="Slide Number Placeholder 3"/>
           <p:cNvSpPr>
             <a:spLocks noGrp="1"/>
           </p:cNvSpPr>
@@ -5624,7 +5611,7 @@
       </p:grpSpPr>
       <p:sp>
         <p:nvSpPr>
-          <p:cNvPr id="28806020" name="TextBox 13"/>
+          <p:cNvPr id="255799801" name="TextBox 13"/>
           <p:cNvSpPr txBox="1"/>
           <p:nvPr/>
         </p:nvSpPr>
@@ -5677,7 +5664,7 @@
       </p:sp>
       <p:sp>
         <p:nvSpPr>
-          <p:cNvPr id="1775105227" name="Slide Number Placeholder 3"/>
+          <p:cNvPr id="716226593" name="Slide Number Placeholder 3"/>
           <p:cNvSpPr>
             <a:spLocks noGrp="1"/>
           </p:cNvSpPr>
@@ -5703,13 +5690,13 @@
       </p:sp>
       <p:pic>
         <p:nvPicPr>
-          <p:cNvPr id="1581573249" name="Picture 1" descr="A graph of a number of individuals&#10;&#10;Description automatically generated"/>
+          <p:cNvPr id="977770737" name="Picture 1" descr="A graph of a number of individuals&#10;&#10;Description automatically generated"/>
           <p:cNvPicPr>
             <a:picLocks noChangeAspect="1"/>
           </p:cNvPicPr>
           <p:nvPr/>
         </p:nvPicPr>
-        <p:blipFill>
+        <p:blipFill rotWithShape="1">
           <a:blip r:embed="rId3"/>
           <a:stretch/>
         </p:blipFill>
@@ -5717,6 +5704,30 @@
           <a:xfrm>
             <a:off x="1981565" y="468147"/>
             <a:ext cx="7810195" cy="4678037"/>
+          </a:xfrm>
+          <a:prstGeom prst="rect">
+            <a:avLst/>
+          </a:prstGeom>
+        </p:spPr>
+      </p:pic>
+      <p:pic>
+        <p:nvPicPr>
+          <p:cNvPr id="977770738" name="Picture 977770737" descr="bill_assist_stacked.png"/>
+          <p:cNvPicPr>
+            <a:picLocks noChangeAspect="1"/>
+          </p:cNvPicPr>
+          <p:nvPr/>
+        </p:nvPicPr>
+        <p:blipFill>
+          <a:blip r:embed="rId4"/>
+          <a:stretch>
+            <a:fillRect/>
+          </a:stretch>
+        </p:blipFill>
+        <p:spPr>
+          <a:xfrm>
+            <a:off x="2209800" y="685800"/>
+            <a:ext cx="7772400" cy="4572000"/>
           </a:xfrm>
           <a:prstGeom prst="rect">
             <a:avLst/>
@@ -5758,7 +5769,7 @@
       </p:grpSpPr>
       <p:sp>
         <p:nvSpPr>
-          <p:cNvPr id="1478670790" name="TextBox 13"/>
+          <p:cNvPr id="1469753875" name="TextBox 13"/>
           <p:cNvSpPr txBox="1"/>
           <p:nvPr/>
         </p:nvSpPr>
@@ -5820,7 +5831,7 @@
       </p:sp>
       <p:sp>
         <p:nvSpPr>
-          <p:cNvPr id="387694404" name="Slide Number Placeholder 3"/>
+          <p:cNvPr id="277550200" name="Slide Number Placeholder 3"/>
           <p:cNvSpPr>
             <a:spLocks noGrp="1"/>
           </p:cNvSpPr>
@@ -5846,13 +5857,13 @@
       </p:sp>
       <p:pic>
         <p:nvPicPr>
-          <p:cNvPr id="614431328" name="Picture 2" descr="A graph with a line going down&#10;&#10;Description automatically generated"/>
+          <p:cNvPr id="811338615" name="Picture 2" descr="A graph with a line going down&#10;&#10;Description automatically generated"/>
           <p:cNvPicPr>
             <a:picLocks noChangeAspect="1"/>
           </p:cNvPicPr>
           <p:nvPr/>
         </p:nvPicPr>
-        <p:blipFill>
+        <p:blipFill rotWithShape="1">
           <a:blip r:embed="rId3"/>
           <a:stretch/>
         </p:blipFill>
@@ -5868,13 +5879,13 @@
       </p:pic>
       <p:pic>
         <p:nvPicPr>
-          <p:cNvPr id="1472269690" name="Picture 4"/>
+          <p:cNvPr id="316813546" name="Picture 4"/>
           <p:cNvPicPr>
             <a:picLocks noChangeAspect="1"/>
           </p:cNvPicPr>
           <p:nvPr/>
         </p:nvPicPr>
-        <p:blipFill>
+        <p:blipFill rotWithShape="1">
           <a:blip r:embed="rId4"/>
           <a:stretch/>
         </p:blipFill>
@@ -5890,13 +5901,13 @@
       </p:pic>
       <p:pic>
         <p:nvPicPr>
-          <p:cNvPr id="1390082395" name="Picture 5" descr="A graph with a line going up&#10;&#10;Description automatically generated"/>
+          <p:cNvPr id="1754764881" name="Picture 5" descr="A graph with a line going up&#10;&#10;Description automatically generated"/>
           <p:cNvPicPr>
             <a:picLocks noChangeAspect="1"/>
           </p:cNvPicPr>
           <p:nvPr/>
         </p:nvPicPr>
-        <p:blipFill>
+        <p:blipFill rotWithShape="1">
           <a:blip r:embed="rId5"/>
           <a:stretch/>
         </p:blipFill>
@@ -5912,13 +5923,13 @@
       </p:pic>
       <p:pic>
         <p:nvPicPr>
-          <p:cNvPr id="46752248" name="Picture 6" descr="A graph showing the number of companies in the bill assistance program&#10;&#10;Description automatically generated"/>
+          <p:cNvPr id="131361708" name="Picture 6" descr="A graph showing the number of companies in the bill assistance program&#10;&#10;Description automatically generated"/>
           <p:cNvPicPr>
             <a:picLocks noChangeAspect="1"/>
           </p:cNvPicPr>
           <p:nvPr/>
         </p:nvPicPr>
-        <p:blipFill>
+        <p:blipFill rotWithShape="1">
           <a:blip r:embed="rId6"/>
           <a:stretch/>
         </p:blipFill>
@@ -5934,13 +5945,13 @@
       </p:pic>
       <p:pic>
         <p:nvPicPr>
-          <p:cNvPr id="1723707604" name="Picture 1" descr="A graph of a number of individuals&#10;&#10;Description automatically generated"/>
+          <p:cNvPr id="564021023" name="Picture 1" descr="A graph of a number of individuals&#10;&#10;Description automatically generated"/>
           <p:cNvPicPr>
             <a:picLocks noChangeAspect="1"/>
           </p:cNvPicPr>
           <p:nvPr/>
         </p:nvPicPr>
-        <p:blipFill>
+        <p:blipFill rotWithShape="1">
           <a:blip r:embed="rId7"/>
           <a:stretch/>
         </p:blipFill>
@@ -5989,13 +6000,13 @@
       </p:grpSpPr>
       <p:pic>
         <p:nvPicPr>
-          <p:cNvPr id="1969836722" name="Picture 4" descr="A graph of a number of customers with a number of payment arrangements&#10;&#10;Description automatically generated"/>
+          <p:cNvPr id="1750098023" name="Picture 4" descr="A graph of a number of customers with a number of payment arrangements&#10;&#10;Description automatically generated"/>
           <p:cNvPicPr>
             <a:picLocks noChangeAspect="1"/>
           </p:cNvPicPr>
           <p:nvPr/>
         </p:nvPicPr>
-        <p:blipFill>
+        <p:blipFill rotWithShape="1">
           <a:blip r:embed="rId3"/>
           <a:stretch/>
         </p:blipFill>
@@ -6011,7 +6022,7 @@
       </p:pic>
       <p:sp>
         <p:nvSpPr>
-          <p:cNvPr id="933811651" name="TextBox 7"/>
+          <p:cNvPr id="75367535" name="TextBox 7"/>
           <p:cNvSpPr txBox="1"/>
           <p:nvPr/>
         </p:nvSpPr>
@@ -6057,7 +6068,7 @@
       </p:sp>
       <p:sp>
         <p:nvSpPr>
-          <p:cNvPr id="183907196" name="Slide Number Placeholder 3"/>
+          <p:cNvPr id="948506406" name="Slide Number Placeholder 3"/>
           <p:cNvSpPr>
             <a:spLocks noGrp="1"/>
           </p:cNvSpPr>
@@ -6083,13 +6094,13 @@
       </p:sp>
       <p:pic>
         <p:nvPicPr>
-          <p:cNvPr id="1496813291" name="Picture 1" descr="A graph of a number of customers with numbers&#10;&#10;Description automatically generated"/>
+          <p:cNvPr id="2027626661" name="Picture 1" descr="A graph of a number of customers with numbers&#10;&#10;Description automatically generated"/>
           <p:cNvPicPr>
             <a:picLocks noChangeAspect="1"/>
           </p:cNvPicPr>
           <p:nvPr/>
         </p:nvPicPr>
-        <p:blipFill>
+        <p:blipFill rotWithShape="1">
           <a:blip r:embed="rId4"/>
           <a:stretch/>
         </p:blipFill>
@@ -6138,7 +6149,7 @@
       </p:grpSpPr>
       <p:sp>
         <p:nvSpPr>
-          <p:cNvPr id="891844175" name="TextBox 6"/>
+          <p:cNvPr id="2072676917" name="TextBox 6"/>
           <p:cNvSpPr txBox="1"/>
           <p:nvPr/>
         </p:nvSpPr>
@@ -6182,7 +6193,7 @@
       </p:sp>
       <p:sp>
         <p:nvSpPr>
-          <p:cNvPr id="1994420480" name="Slide Number Placeholder 3"/>
+          <p:cNvPr id="846492561" name="Slide Number Placeholder 3"/>
           <p:cNvSpPr>
             <a:spLocks noGrp="1"/>
           </p:cNvSpPr>
@@ -6208,13 +6219,13 @@
       </p:sp>
       <p:pic>
         <p:nvPicPr>
-          <p:cNvPr id="1607017745" name="Picture 1" descr="A graph of a number of utility bills&#10;&#10;Description automatically generated"/>
+          <p:cNvPr id="1416101740" name="Picture 1" descr="A graph of a number of utility bills&#10;&#10;Description automatically generated"/>
           <p:cNvPicPr>
             <a:picLocks noChangeAspect="1"/>
           </p:cNvPicPr>
           <p:nvPr/>
         </p:nvPicPr>
-        <p:blipFill>
+        <p:blipFill rotWithShape="1">
           <a:blip r:embed="rId3"/>
           <a:stretch/>
         </p:blipFill>
@@ -6263,7 +6274,7 @@
       </p:grpSpPr>
       <p:sp>
         <p:nvSpPr>
-          <p:cNvPr id="1944258538" name="Slide Number Placeholder 1"/>
+          <p:cNvPr id="1436320886" name="Slide Number Placeholder 1"/>
           <p:cNvSpPr>
             <a:spLocks noGrp="1"/>
           </p:cNvSpPr>
@@ -6289,7 +6300,7 @@
       </p:sp>
       <p:sp>
         <p:nvSpPr>
-          <p:cNvPr id="2054630898" name="TextBox 3"/>
+          <p:cNvPr id="577929171" name="TextBox 3"/>
           <p:cNvSpPr txBox="1"/>
           <p:nvPr/>
         </p:nvSpPr>
@@ -6332,13 +6343,13 @@
       </p:sp>
       <p:pic>
         <p:nvPicPr>
-          <p:cNvPr id="1894058258" name="Picture 4" descr="A graph of different colored bars&#10;&#10;Description automatically generated"/>
+          <p:cNvPr id="1925107225" name="Picture 4" descr="A graph of different colored bars&#10;&#10;Description automatically generated"/>
           <p:cNvPicPr>
             <a:picLocks noChangeAspect="1"/>
           </p:cNvPicPr>
           <p:nvPr/>
         </p:nvPicPr>
-        <p:blipFill>
+        <p:blipFill rotWithShape="1">
           <a:blip r:embed="rId3"/>
           <a:stretch/>
         </p:blipFill>
@@ -6387,7 +6398,7 @@
       </p:grpSpPr>
       <p:sp>
         <p:nvSpPr>
-          <p:cNvPr id="80757715" name="TextBox 3"/>
+          <p:cNvPr id="1263256198" name="TextBox 3"/>
           <p:cNvSpPr txBox="1"/>
           <p:nvPr/>
         </p:nvSpPr>
@@ -6423,7 +6434,7 @@
       </p:sp>
       <p:sp>
         <p:nvSpPr>
-          <p:cNvPr id="1963690643" name="Slide Number Placeholder 1"/>
+          <p:cNvPr id="673387581" name="Slide Number Placeholder 1"/>
           <p:cNvSpPr>
             <a:spLocks noGrp="1"/>
           </p:cNvSpPr>
@@ -6482,7 +6493,7 @@
       </p:grpSpPr>
       <p:sp>
         <p:nvSpPr>
-          <p:cNvPr id="621925342" name="TextBox 5"/>
+          <p:cNvPr id="2041408913" name="TextBox 5"/>
           <p:cNvSpPr txBox="1"/>
           <p:nvPr/>
         </p:nvSpPr>
@@ -6535,7 +6546,7 @@
       </p:sp>
       <p:sp>
         <p:nvSpPr>
-          <p:cNvPr id="1314293371" name="Slide Number Placeholder 3"/>
+          <p:cNvPr id="587777116" name="Slide Number Placeholder 3"/>
           <p:cNvSpPr>
             <a:spLocks noGrp="1"/>
           </p:cNvSpPr>
@@ -6561,13 +6572,13 @@
       </p:sp>
       <p:pic>
         <p:nvPicPr>
-          <p:cNvPr id="1378137317" name="Picture 1" descr="A graph of a number of people&#10;&#10;Description automatically generated"/>
+          <p:cNvPr id="372412490" name="Picture 1" descr="A graph of a number of people&#10;&#10;Description automatically generated"/>
           <p:cNvPicPr>
             <a:picLocks noChangeAspect="1"/>
           </p:cNvPicPr>
           <p:nvPr/>
         </p:nvPicPr>
-        <p:blipFill>
+        <p:blipFill rotWithShape="1">
           <a:blip r:embed="rId3"/>
           <a:stretch/>
         </p:blipFill>
@@ -6575,6 +6586,30 @@
           <a:xfrm>
             <a:off x="2306053" y="569805"/>
             <a:ext cx="7573210" cy="4481812"/>
+          </a:xfrm>
+          <a:prstGeom prst="rect">
+            <a:avLst/>
+          </a:prstGeom>
+        </p:spPr>
+      </p:pic>
+      <p:pic>
+        <p:nvPicPr>
+          <p:cNvPr id="2041408914" name="Picture 2041408913" descr="disconnections_stacked.png"/>
+          <p:cNvPicPr>
+            <a:picLocks noChangeAspect="1"/>
+          </p:cNvPicPr>
+          <p:nvPr/>
+        </p:nvPicPr>
+        <p:blipFill>
+          <a:blip r:embed="rId4"/>
+          <a:stretch>
+            <a:fillRect/>
+          </a:stretch>
+        </p:blipFill>
+        <p:spPr>
+          <a:xfrm>
+            <a:off x="2209800" y="685800"/>
+            <a:ext cx="7772400" cy="4572000"/>
           </a:xfrm>
           <a:prstGeom prst="rect">
             <a:avLst/>
@@ -6616,7 +6651,7 @@
       </p:grpSpPr>
       <p:sp>
         <p:nvSpPr>
-          <p:cNvPr id="1208864836" name="TextBox 3"/>
+          <p:cNvPr id="2036889051" name="TextBox 3"/>
           <p:cNvSpPr txBox="1"/>
           <p:nvPr/>
         </p:nvSpPr>
@@ -6655,7 +6690,7 @@
       </p:sp>
       <p:sp>
         <p:nvSpPr>
-          <p:cNvPr id="381745151" name="Slide Number Placeholder 1"/>
+          <p:cNvPr id="1712682798" name="Slide Number Placeholder 1"/>
           <p:cNvSpPr>
             <a:spLocks noGrp="1"/>
           </p:cNvSpPr>
@@ -6714,7 +6749,7 @@
       </p:grpSpPr>
       <p:sp>
         <p:nvSpPr>
-          <p:cNvPr id="1126884205" name="TextBox 3"/>
+          <p:cNvPr id="384011172" name="TextBox 3"/>
           <p:cNvSpPr txBox="1"/>
           <p:nvPr/>
         </p:nvSpPr>
@@ -6779,7 +6814,7 @@
       </p:sp>
       <p:sp>
         <p:nvSpPr>
-          <p:cNvPr id="1469288126" name="Slide Number Placeholder 4"/>
+          <p:cNvPr id="1007194882" name="Slide Number Placeholder 4"/>
           <p:cNvSpPr>
             <a:spLocks noGrp="1"/>
           </p:cNvSpPr>
@@ -6805,13 +6840,13 @@
       </p:sp>
       <p:pic>
         <p:nvPicPr>
-          <p:cNvPr id="1549169814" name="Picture 5" descr="A graph of a number of customers&#10;&#10;Description automatically generated"/>
+          <p:cNvPr id="1323730483" name="Picture 5" descr="A graph of a number of customers&#10;&#10;Description automatically generated"/>
           <p:cNvPicPr>
             <a:picLocks noChangeAspect="1"/>
           </p:cNvPicPr>
           <p:nvPr/>
         </p:nvPicPr>
-        <p:blipFill>
+        <p:blipFill rotWithShape="1">
           <a:blip r:embed="rId3"/>
           <a:stretch/>
         </p:blipFill>
@@ -6827,13 +6862,13 @@
       </p:pic>
       <p:pic>
         <p:nvPicPr>
-          <p:cNvPr id="1866272136" name="Picture 6" descr="A graph of bad debt&#10;&#10;Description automatically generated"/>
+          <p:cNvPr id="1225823882" name="Picture 6" descr="A graph of bad debt&#10;&#10;Description automatically generated"/>
           <p:cNvPicPr>
             <a:picLocks noChangeAspect="1"/>
           </p:cNvPicPr>
           <p:nvPr/>
         </p:nvPicPr>
-        <p:blipFill>
+        <p:blipFill rotWithShape="1">
           <a:blip r:embed="rId4"/>
           <a:stretch/>
         </p:blipFill>
@@ -6882,7 +6917,7 @@
       </p:grpSpPr>
       <p:sp>
         <p:nvSpPr>
-          <p:cNvPr id="56084739" name="Slide Number Placeholder 1"/>
+          <p:cNvPr id="641261881" name="Slide Number Placeholder 1"/>
           <p:cNvSpPr>
             <a:spLocks noGrp="1"/>
           </p:cNvSpPr>
@@ -6908,7 +6943,7 @@
       </p:sp>
       <p:sp>
         <p:nvSpPr>
-          <p:cNvPr id="1602242362" name="TextBox 3"/>
+          <p:cNvPr id="1218738911" name="TextBox 3"/>
           <p:cNvSpPr txBox="1"/>
           <p:nvPr/>
         </p:nvSpPr>
@@ -7062,7 +7097,7 @@
       </p:sp>
       <p:sp>
         <p:nvSpPr>
-          <p:cNvPr id="141238924" name="TextBox 5"/>
+          <p:cNvPr id="820012702" name="TextBox 5"/>
           <p:cNvSpPr txBox="1"/>
           <p:nvPr/>
         </p:nvSpPr>
@@ -7131,7 +7166,7 @@
       </p:grpSpPr>
       <p:sp>
         <p:nvSpPr>
-          <p:cNvPr id="1571030620" name="Title 1"/>
+          <p:cNvPr id="877750764" name="Title 1"/>
           <p:cNvSpPr>
             <a:spLocks noGrp="1"/>
           </p:cNvSpPr>
@@ -7160,7 +7195,7 @@
       </p:sp>
       <p:sp>
         <p:nvSpPr>
-          <p:cNvPr id="737409359" name="Content Placeholder 2"/>
+          <p:cNvPr id="343817841" name="Content Placeholder 2"/>
           <p:cNvSpPr>
             <a:spLocks noGrp="1"/>
           </p:cNvSpPr>
@@ -7384,7 +7419,7 @@
       </p:sp>
       <p:sp>
         <p:nvSpPr>
-          <p:cNvPr id="1328227270" name="Slide Number Placeholder 3"/>
+          <p:cNvPr id="170526518" name="Slide Number Placeholder 3"/>
           <p:cNvSpPr>
             <a:spLocks noGrp="1"/>
           </p:cNvSpPr>
@@ -7443,7 +7478,7 @@
       </p:grpSpPr>
       <p:sp>
         <p:nvSpPr>
-          <p:cNvPr id="1924584654" name="TextBox 3"/>
+          <p:cNvPr id="1831838564" name="TextBox 3"/>
           <p:cNvSpPr txBox="1"/>
           <p:nvPr/>
         </p:nvSpPr>
@@ -7479,7 +7514,7 @@
       </p:sp>
       <p:sp>
         <p:nvSpPr>
-          <p:cNvPr id="1210308161" name="Slide Number Placeholder 1"/>
+          <p:cNvPr id="790824342" name="Slide Number Placeholder 1"/>
           <p:cNvSpPr>
             <a:spLocks noGrp="1"/>
           </p:cNvSpPr>
@@ -7538,7 +7573,7 @@
       </p:grpSpPr>
       <p:sp>
         <p:nvSpPr>
-          <p:cNvPr id="1995566841" name="Slide Number Placeholder 1"/>
+          <p:cNvPr id="1873587093" name="Slide Number Placeholder 1"/>
           <p:cNvSpPr>
             <a:spLocks noGrp="1"/>
           </p:cNvSpPr>
@@ -7564,7 +7599,7 @@
       </p:sp>
       <p:sp>
         <p:nvSpPr>
-          <p:cNvPr id="229268071" name="TextBox 4"/>
+          <p:cNvPr id="1112406232" name="TextBox 4"/>
           <p:cNvSpPr txBox="1"/>
           <p:nvPr/>
         </p:nvSpPr>
@@ -8445,7 +8480,7 @@
       </p:grpSpPr>
       <p:sp>
         <p:nvSpPr>
-          <p:cNvPr id="1569884430" name="Slide Number Placeholder 1"/>
+          <p:cNvPr id="39774545" name="Slide Number Placeholder 1"/>
           <p:cNvSpPr>
             <a:spLocks noGrp="1"/>
           </p:cNvSpPr>
@@ -8471,7 +8506,7 @@
       </p:sp>
       <p:sp>
         <p:nvSpPr>
-          <p:cNvPr id="128982866" name="TextBox 4"/>
+          <p:cNvPr id="63477788" name="TextBox 4"/>
           <p:cNvSpPr txBox="1"/>
           <p:nvPr/>
         </p:nvSpPr>
@@ -8684,7 +8719,7 @@
       </p:grpSpPr>
       <p:sp>
         <p:nvSpPr>
-          <p:cNvPr id="801548256" name="Title 1"/>
+          <p:cNvPr id="1165791380" name="Title 1"/>
           <p:cNvSpPr>
             <a:spLocks noGrp="1"/>
           </p:cNvSpPr>
@@ -8718,7 +8753,7 @@
       </p:sp>
       <p:sp>
         <p:nvSpPr>
-          <p:cNvPr id="251432923" name="Content Placeholder 2"/>
+          <p:cNvPr id="656100748" name="Content Placeholder 2"/>
           <p:cNvSpPr>
             <a:spLocks noGrp="1"/>
           </p:cNvSpPr>
@@ -8747,7 +8782,7 @@
       </p:sp>
       <p:sp>
         <p:nvSpPr>
-          <p:cNvPr id="471000163" name="Slide Number Placeholder 3"/>
+          <p:cNvPr id="1351463708" name="Slide Number Placeholder 3"/>
           <p:cNvSpPr>
             <a:spLocks noGrp="1"/>
           </p:cNvSpPr>
@@ -8806,7 +8841,7 @@
       </p:grpSpPr>
       <p:sp>
         <p:nvSpPr>
-          <p:cNvPr id="1237292380" name="TextBox 3"/>
+          <p:cNvPr id="1165474054" name="TextBox 3"/>
           <p:cNvSpPr txBox="1"/>
           <p:nvPr/>
         </p:nvSpPr>
@@ -8842,7 +8877,7 @@
       </p:sp>
       <p:sp>
         <p:nvSpPr>
-          <p:cNvPr id="704301583" name="Slide Number Placeholder 1"/>
+          <p:cNvPr id="247049874" name="Slide Number Placeholder 1"/>
           <p:cNvSpPr>
             <a:spLocks noGrp="1"/>
           </p:cNvSpPr>
@@ -8901,7 +8936,7 @@
       </p:grpSpPr>
       <p:sp>
         <p:nvSpPr>
-          <p:cNvPr id="1073100270" name="TextBox 5"/>
+          <p:cNvPr id="1601572707" name="TextBox 5"/>
           <p:cNvSpPr txBox="1"/>
           <p:nvPr/>
         </p:nvSpPr>
@@ -8943,7 +8978,7 @@
       </p:sp>
       <p:sp>
         <p:nvSpPr>
-          <p:cNvPr id="642556273" name="Slide Number Placeholder 3"/>
+          <p:cNvPr id="304956011" name="Slide Number Placeholder 3"/>
           <p:cNvSpPr>
             <a:spLocks noGrp="1"/>
           </p:cNvSpPr>
@@ -8969,7 +9004,7 @@
       </p:sp>
       <p:pic>
         <p:nvPicPr>
-          <p:cNvPr id="1073100271" name="Picture 1073100270" descr="arrearage_counts_stacked.png"/>
+          <p:cNvPr id="1601572708" name="Picture 1601572707" descr="arrearage_counts_stacked.png"/>
           <p:cNvPicPr>
             <a:picLocks noChangeAspect="1"/>
           </p:cNvPicPr>
@@ -9026,13 +9061,13 @@
       </p:grpSpPr>
       <p:pic>
         <p:nvPicPr>
-          <p:cNvPr id="652655657" name="Picture 6" descr="A table with numbers and symbols&#10;&#10;Description automatically generated"/>
+          <p:cNvPr id="1608052938" name="Picture 6" descr="A table with numbers and symbols&#10;&#10;Description automatically generated"/>
           <p:cNvPicPr>
             <a:picLocks noChangeAspect="1"/>
           </p:cNvPicPr>
           <p:nvPr/>
         </p:nvPicPr>
-        <p:blipFill>
+        <p:blipFill rotWithShape="1">
           <a:blip r:embed="rId3"/>
           <a:stretch/>
         </p:blipFill>
@@ -9053,13 +9088,13 @@
       </p:pic>
       <p:pic>
         <p:nvPicPr>
-          <p:cNvPr id="168885017" name="Picture 8"/>
+          <p:cNvPr id="1155395807" name="Picture 8"/>
           <p:cNvPicPr>
             <a:picLocks noChangeAspect="1"/>
           </p:cNvPicPr>
           <p:nvPr/>
         </p:nvPicPr>
-        <p:blipFill>
+        <p:blipFill rotWithShape="1">
           <a:blip r:embed="rId4"/>
           <a:stretch/>
         </p:blipFill>
@@ -9080,7 +9115,7 @@
       </p:pic>
       <p:sp>
         <p:nvSpPr>
-          <p:cNvPr id="348702396" name="TextBox 9"/>
+          <p:cNvPr id="1755934690" name="TextBox 9"/>
           <p:cNvSpPr txBox="1"/>
           <p:nvPr/>
         </p:nvSpPr>
@@ -9131,7 +9166,7 @@
       </p:sp>
       <p:sp>
         <p:nvSpPr>
-          <p:cNvPr id="695177626" name="Slide Number Placeholder 3"/>
+          <p:cNvPr id="386667770" name="Slide Number Placeholder 3"/>
           <p:cNvSpPr>
             <a:spLocks noGrp="1"/>
           </p:cNvSpPr>
@@ -9155,6 +9190,30 @@
           </a:p>
         </p:txBody>
       </p:sp>
+      <p:pic>
+        <p:nvPicPr>
+          <p:cNvPr id="1755934691" name="Picture 1755934690" descr="arrearage_amounts_stacked.png"/>
+          <p:cNvPicPr>
+            <a:picLocks noChangeAspect="1"/>
+          </p:cNvPicPr>
+          <p:nvPr/>
+        </p:nvPicPr>
+        <p:blipFill>
+          <a:blip r:embed="rId5"/>
+          <a:stretch>
+            <a:fillRect/>
+          </a:stretch>
+        </p:blipFill>
+        <p:spPr>
+          <a:xfrm>
+            <a:off x="889000" y="685800"/>
+            <a:ext cx="6858000" cy="4114800"/>
+          </a:xfrm>
+          <a:prstGeom prst="rect">
+            <a:avLst/>
+          </a:prstGeom>
+        </p:spPr>
+      </p:pic>
     </p:spTree>
   </p:cSld>
   <p:clrMapOvr>
@@ -9190,7 +9249,7 @@
       </p:grpSpPr>
       <p:sp>
         <p:nvSpPr>
-          <p:cNvPr id="357445344" name="Slide Number Placeholder 1"/>
+          <p:cNvPr id="1308707931" name="Slide Number Placeholder 1"/>
           <p:cNvSpPr>
             <a:spLocks noGrp="1"/>
           </p:cNvSpPr>
@@ -9216,7 +9275,7 @@
       </p:sp>
       <p:sp>
         <p:nvSpPr>
-          <p:cNvPr id="2082306951" name="TextBox 3"/>
+          <p:cNvPr id="507654454" name="TextBox 3"/>
           <p:cNvSpPr txBox="1"/>
           <p:nvPr/>
         </p:nvSpPr>
@@ -9256,6 +9315,54 @@
           </a:p>
         </p:txBody>
       </p:sp>
+      <p:pic>
+        <p:nvPicPr>
+          <p:cNvPr id="1308707932" name="Picture 1308707931" descr="arrearage_amounts_vintage.png"/>
+          <p:cNvPicPr>
+            <a:picLocks noChangeAspect="1"/>
+          </p:cNvPicPr>
+          <p:nvPr/>
+        </p:nvPicPr>
+        <p:blipFill>
+          <a:blip r:embed="rId3"/>
+          <a:stretch>
+            <a:fillRect/>
+          </a:stretch>
+        </p:blipFill>
+        <p:spPr>
+          <a:xfrm>
+            <a:off x="457200" y="800100"/>
+            <a:ext cx="5486400" cy="3657600"/>
+          </a:xfrm>
+          <a:prstGeom prst="rect">
+            <a:avLst/>
+          </a:prstGeom>
+        </p:spPr>
+      </p:pic>
+      <p:pic>
+        <p:nvPicPr>
+          <p:cNvPr id="1308707933" name="Picture 1308707932" descr="kli_arrearage_amounts_vintage.png"/>
+          <p:cNvPicPr>
+            <a:picLocks noChangeAspect="1"/>
+          </p:cNvPicPr>
+          <p:nvPr/>
+        </p:nvPicPr>
+        <p:blipFill>
+          <a:blip r:embed="rId4"/>
+          <a:stretch>
+            <a:fillRect/>
+          </a:stretch>
+        </p:blipFill>
+        <p:spPr>
+          <a:xfrm>
+            <a:off x="5943600" y="800100"/>
+            <a:ext cx="5486400" cy="3657600"/>
+          </a:xfrm>
+          <a:prstGeom prst="rect">
+            <a:avLst/>
+          </a:prstGeom>
+        </p:spPr>
+      </p:pic>
     </p:spTree>
   </p:cSld>
   <p:clrMapOvr>
@@ -9291,7 +9398,7 @@
       </p:grpSpPr>
       <p:sp>
         <p:nvSpPr>
-          <p:cNvPr id="1837021906" name="TextBox 3"/>
+          <p:cNvPr id="721203210" name="TextBox 3"/>
           <p:cNvSpPr txBox="1"/>
           <p:nvPr/>
         </p:nvSpPr>
@@ -9332,7 +9439,7 @@
       </p:sp>
       <p:sp>
         <p:nvSpPr>
-          <p:cNvPr id="664165301" name="Slide Number Placeholder 4"/>
+          <p:cNvPr id="1572366773" name="Slide Number Placeholder 4"/>
           <p:cNvSpPr>
             <a:spLocks noGrp="1"/>
           </p:cNvSpPr>
@@ -9391,7 +9498,7 @@
       </p:grpSpPr>
       <p:sp>
         <p:nvSpPr>
-          <p:cNvPr id="950161098" name="TextBox 3"/>
+          <p:cNvPr id="1086181929" name="TextBox 3"/>
           <p:cNvSpPr txBox="1"/>
           <p:nvPr/>
         </p:nvSpPr>
@@ -9427,7 +9534,7 @@
       </p:sp>
       <p:sp>
         <p:nvSpPr>
-          <p:cNvPr id="1800995089" name="Slide Number Placeholder 1"/>
+          <p:cNvPr id="498064587" name="Slide Number Placeholder 1"/>
           <p:cNvSpPr>
             <a:spLocks noGrp="1"/>
           </p:cNvSpPr>

</xml_diff>